<commit_message>
Upgraded MAF to 1.22
</commit_message>
<xml_diff>
--- a/Projects/Module02-MicrosoftAgentFrameworkFundamentals/Module02 - Microsoft Agent Framework Fundamentals.pptx
+++ b/Projects/Module02-MicrosoftAgentFrameworkFundamentals/Module02 - Microsoft Agent Framework Fundamentals.pptx
@@ -2420,7 +2420,7 @@
                 <a:ea typeface="Courier New" pitchFamily="34" charset="-122"/>
                 <a:cs typeface="Courier New" pitchFamily="34" charset="-120"/>
               </a:rPr>
-              <a:t>1.20.0</a:t>
+              <a:t>1.22.0</a:t>
             </a:r>
             <a:endParaRPr lang="en-US" sz="950" dirty="0"/>
           </a:p>
@@ -2557,7 +2557,7 @@
                 <a:ea typeface="Courier New" pitchFamily="34" charset="-122"/>
                 <a:cs typeface="Courier New" pitchFamily="34" charset="-120"/>
               </a:rPr>
-              <a:t>10.9.0</a:t>
+              <a:t>10.10.0</a:t>
             </a:r>
             <a:endParaRPr lang="en-US" sz="950" dirty="0"/>
           </a:p>
@@ -4602,7 +4602,7 @@
                 <a:ea typeface="Courier New" pitchFamily="34" charset="-122"/>
                 <a:cs typeface="Courier New" pitchFamily="34" charset="-120"/>
               </a:rPr>
-              <a:t>                    Version="1.20.0" /&gt;</a:t>
+              <a:t>                    Version="1.22.0" /&gt;</a:t>
             </a:r>
             <a:endParaRPr lang="en-US" sz="950" dirty="0"/>
           </a:p>
@@ -4662,7 +4662,7 @@
                 <a:ea typeface="Courier New" pitchFamily="34" charset="-122"/>
                 <a:cs typeface="Courier New" pitchFamily="34" charset="-120"/>
               </a:rPr>
-              <a:t>      Version="10.9.0" /&gt;</a:t>
+              <a:t>      Version="10.10.0" /&gt;</a:t>
             </a:r>
             <a:endParaRPr lang="en-US" sz="950" dirty="0"/>
           </a:p>

</xml_diff>